<commit_message>
Stamp the Cloud Run chat URL and QR codes into the Career Day deck
Replaces the placeholder address on the demo slide and the closing slide
with the deployed service URL, via scripts/set_deck_chat_url.py.

Co-Authored-By: Claude Fable 5.1 <noreply@anthropic.com>
Claude-Session: https://claude.ai/code/session_01RLqmMGqvBXB1NeMETbbxPA
</commit_message>
<xml_diff>
--- a/docs/Career_Day_2026_EWMS.pptx
+++ b/docs/Career_Day_2026_EWMS.pptx
@@ -7370,7 +7370,7 @@
                 <a:ea typeface="Nunito Sans" pitchFamily="34" charset="-122"/>
                 <a:cs typeface="Nunito Sans" pitchFamily="34" charset="-120"/>
               </a:rPr>
-              <a:t>YOUR-CLOUD-RUN-URL.a.run.app</a:t>
+              <a:t>willkie-badger-ai-424903425639.us-central1.run.app</a:t>
             </a:r>
           </a:p>
         </p:txBody>
@@ -14104,7 +14104,7 @@
                 <a:ea typeface="Nunito Sans" pitchFamily="34" charset="-122"/>
                 <a:cs typeface="Nunito Sans" pitchFamily="34" charset="-120"/>
               </a:rPr>
-              <a:t>YOUR-CLOUD-RUN-URL.a.run.app</a:t>
+              <a:t>willkie-badger-ai-424903425639.us-central1.run.app</a:t>
             </a:r>
           </a:p>
         </p:txBody>

</xml_diff>